<commit_message>
Add 26 Aug biweekly review summary and correct the 0826 deck
Keith corrected the PFD position in the meeting: the CIP revision still
drives a PFD update even though the reactor/TCU change no longer does.
HAZOP is also no longer expected in September, so the next-steps line now
carries the proposed on-site session instead.

Co-authored-by: peterli0913 <peterli0913@users.noreply.github.com>
</commit_message>
<xml_diff>
--- a/Progress_Report_0826.pptx
+++ b/Progress_Report_0826.pptx
@@ -4025,7 +4025,7 @@
                 <a:latin typeface="Segoe UI"/>
                 <a:ea typeface="Microsoft YaHei"/>
               </a:rPr>
-              <a:t>PFD and mass balance confirmed unchanged — the consequential re-work is avoided</a:t>
+              <a:t>Reactor size no longer drives a PFD change — but the CIP revision still requires a PFD review and update</a:t>
             </a:r>
           </a:p>
           <a:p>
@@ -4042,7 +4042,7 @@
                 <a:latin typeface="Microsoft YaHei"/>
                 <a:ea typeface="Microsoft YaHei"/>
               </a:rPr>
-              <a:t>     PFD 与物料平衡确认不改，连带的配置调整全部免除</a:t>
+              <a:t>     反应器尺寸不再驱动 PFD 变更，但 CIP 修改仍需 PFD 复核升版</a:t>
             </a:r>
           </a:p>
           <a:p>
@@ -5726,7 +5726,7 @@
                 <a:latin typeface="Segoe UI"/>
                 <a:ea typeface="Microsoft YaHei"/>
               </a:rPr>
-              <a:t>Send tracker responses to Keith for line-by-line closure this week; HAZOP early September with the 3D layout and control philosophy agreed first, run once only</a:t>
+              <a:t>Send tracker responses to Keith for closure, and submit the proposal for a one-week on-site session at Sandwich — HAZOP follows once the layout is fixed</a:t>
             </a:r>
           </a:p>
           <a:p>
@@ -5743,7 +5743,7 @@
                 <a:latin typeface="Microsoft YaHei"/>
                 <a:ea typeface="Microsoft YaHei"/>
               </a:rPr>
-              <a:t>     本周将跟踪表答复发 Keith 逐条关闭；9 月初 HAZOP 前先谈定 3D 与控制说明，确保只做一次</a:t>
+              <a:t>     将跟踪表答复发 Keith 逐条关闭；提交赴 Sandwich 现场集中一周的行程申请——HAZOP 待布置定案后再排</a:t>
             </a:r>
           </a:p>
         </p:txBody>

</xml_diff>